<commit_message>
feat: add scientific diagrams to Aufbau der Erde presentation
Earth sphere, cross-section, tectonic plates, convection, core+magnetic field

https://claude.ai/code/session_015LB2xF2RT5mgKYrcesBYZQ
</commit_message>
<xml_diff>
--- a/Aufbau_der_Erde.pptx
+++ b/Aufbau_der_Erde.pptx
@@ -3102,6 +3102,30 @@
         <p:nvPr/>
       </p:nvGrpSpPr>
       <p:grpSpPr/>
+      <p:pic>
+        <p:nvPicPr>
+          <p:cNvPr id="15" name="Picture 14" descr="image.png"/>
+          <p:cNvPicPr>
+            <a:picLocks noChangeAspect="1"/>
+          </p:cNvPicPr>
+          <p:nvPr/>
+        </p:nvPicPr>
+        <p:blipFill>
+          <a:blip r:embed="rId2"/>
+          <a:stretch>
+            <a:fillRect/>
+          </a:stretch>
+        </p:blipFill>
+        <p:spPr>
+          <a:xfrm>
+            <a:off x="5486400" y="822960"/>
+            <a:ext cx="3474720" cy="3672468"/>
+          </a:xfrm>
+          <a:prstGeom prst="rect">
+            <a:avLst/>
+          </a:prstGeom>
+        </p:spPr>
+      </p:pic>
       <p:sp>
         <p:nvSpPr>
           <p:cNvPr id="2" name="Rectangle 1"/>
@@ -3647,6 +3671,30 @@
         <p:nvPr/>
       </p:nvGrpSpPr>
       <p:grpSpPr/>
+      <p:pic>
+        <p:nvPicPr>
+          <p:cNvPr id="31" name="Picture 30" descr="image.png"/>
+          <p:cNvPicPr>
+            <a:picLocks noChangeAspect="1"/>
+          </p:cNvPicPr>
+          <p:nvPr/>
+        </p:nvPicPr>
+        <p:blipFill>
+          <a:blip r:embed="rId2"/>
+          <a:stretch>
+            <a:fillRect/>
+          </a:stretch>
+        </p:blipFill>
+        <p:spPr>
+          <a:xfrm>
+            <a:off x="5486400" y="822960"/>
+            <a:ext cx="3474720" cy="3645608"/>
+          </a:xfrm>
+          <a:prstGeom prst="rect">
+            <a:avLst/>
+          </a:prstGeom>
+        </p:spPr>
+      </p:pic>
       <p:sp>
         <p:nvSpPr>
           <p:cNvPr id="2" name="Rectangle 1"/>
@@ -4785,6 +4833,30 @@
         <p:nvPr/>
       </p:nvGrpSpPr>
       <p:grpSpPr/>
+      <p:pic>
+        <p:nvPicPr>
+          <p:cNvPr id="22" name="Picture 21" descr="image.png"/>
+          <p:cNvPicPr>
+            <a:picLocks noChangeAspect="1"/>
+          </p:cNvPicPr>
+          <p:nvPr/>
+        </p:nvPicPr>
+        <p:blipFill>
+          <a:blip r:embed="rId2"/>
+          <a:stretch>
+            <a:fillRect/>
+          </a:stretch>
+        </p:blipFill>
+        <p:spPr>
+          <a:xfrm>
+            <a:off x="5303520" y="1371600"/>
+            <a:ext cx="3657600" cy="2406473"/>
+          </a:xfrm>
+          <a:prstGeom prst="rect">
+            <a:avLst/>
+          </a:prstGeom>
+        </p:spPr>
+      </p:pic>
       <p:sp>
         <p:nvSpPr>
           <p:cNvPr id="2" name="Rectangle 1"/>
@@ -5600,6 +5672,30 @@
         <p:nvPr/>
       </p:nvGrpSpPr>
       <p:grpSpPr/>
+      <p:pic>
+        <p:nvPicPr>
+          <p:cNvPr id="22" name="Picture 21" descr="image.png"/>
+          <p:cNvPicPr>
+            <a:picLocks noChangeAspect="1"/>
+          </p:cNvPicPr>
+          <p:nvPr/>
+        </p:nvPicPr>
+        <p:blipFill>
+          <a:blip r:embed="rId2"/>
+          <a:stretch>
+            <a:fillRect/>
+          </a:stretch>
+        </p:blipFill>
+        <p:spPr>
+          <a:xfrm>
+            <a:off x="5212080" y="1371600"/>
+            <a:ext cx="3657600" cy="3042488"/>
+          </a:xfrm>
+          <a:prstGeom prst="rect">
+            <a:avLst/>
+          </a:prstGeom>
+        </p:spPr>
+      </p:pic>
       <p:sp>
         <p:nvSpPr>
           <p:cNvPr id="2" name="Rectangle 1"/>
@@ -6417,6 +6513,30 @@
         <p:nvPr/>
       </p:nvGrpSpPr>
       <p:grpSpPr/>
+      <p:pic>
+        <p:nvPicPr>
+          <p:cNvPr id="22" name="Picture 21" descr="image.png"/>
+          <p:cNvPicPr>
+            <a:picLocks noChangeAspect="1"/>
+          </p:cNvPicPr>
+          <p:nvPr/>
+        </p:nvPicPr>
+        <p:blipFill>
+          <a:blip r:embed="rId2"/>
+          <a:stretch>
+            <a:fillRect/>
+          </a:stretch>
+        </p:blipFill>
+        <p:spPr>
+          <a:xfrm>
+            <a:off x="5577840" y="731520"/>
+            <a:ext cx="3291840" cy="4095248"/>
+          </a:xfrm>
+          <a:prstGeom prst="rect">
+            <a:avLst/>
+          </a:prstGeom>
+        </p:spPr>
+      </p:pic>
       <p:sp>
         <p:nvSpPr>
           <p:cNvPr id="2" name="Rectangle 1"/>
@@ -9756,6 +9876,30 @@
         <p:nvPr/>
       </p:nvGrpSpPr>
       <p:grpSpPr/>
+      <p:pic>
+        <p:nvPicPr>
+          <p:cNvPr id="14" name="Picture 13" descr="image.png"/>
+          <p:cNvPicPr>
+            <a:picLocks noChangeAspect="1"/>
+          </p:cNvPicPr>
+          <p:nvPr/>
+        </p:nvPicPr>
+        <p:blipFill>
+          <a:blip r:embed="rId2"/>
+          <a:stretch>
+            <a:fillRect/>
+          </a:stretch>
+        </p:blipFill>
+        <p:spPr>
+          <a:xfrm>
+            <a:off x="3200400" y="1371600"/>
+            <a:ext cx="2743200" cy="2899317"/>
+          </a:xfrm>
+          <a:prstGeom prst="rect">
+            <a:avLst/>
+          </a:prstGeom>
+        </p:spPr>
+      </p:pic>
       <p:sp>
         <p:nvSpPr>
           <p:cNvPr id="2" name="Rectangle 1"/>

</xml_diff>

<commit_message>
Add scientific diagrams to Aufbau der Erde presentation (#2)
* feat: Karteikarten für Aufbau der Erde Referat

https://claude.ai/code/session_015LB2xF2RT5mgKYrcesBYZQ

* refactor: Karteikarten auf Stichwörter gekürzt

https://claude.ai/code/session_015LB2xF2RT5mgKYrcesBYZQ

* refactor: Karteikarten auf 2 Personen à 2 Min aufgeteilt

https://claude.ai/code/session_015LB2xF2RT5mgKYrcesBYZQ

* feat: Karteikarten für Goethe Referat (1 Person, ~2 Min)

https://claude.ai/code/session_015LB2xF2RT5mgKYrcesBYZQ

* feat: add scientific diagrams to Aufbau der Erde presentation

Earth sphere, cross-section, tectonic plates, convection, core+magnetic field

https://claude.ai/code/session_015LB2xF2RT5mgKYrcesBYZQ

---------

Co-authored-by: Claude <noreply@anthropic.com>
</commit_message>
<xml_diff>
--- a/Aufbau_der_Erde.pptx
+++ b/Aufbau_der_Erde.pptx
@@ -3102,6 +3102,30 @@
         <p:nvPr/>
       </p:nvGrpSpPr>
       <p:grpSpPr/>
+      <p:pic>
+        <p:nvPicPr>
+          <p:cNvPr id="15" name="Picture 14" descr="image.png"/>
+          <p:cNvPicPr>
+            <a:picLocks noChangeAspect="1"/>
+          </p:cNvPicPr>
+          <p:nvPr/>
+        </p:nvPicPr>
+        <p:blipFill>
+          <a:blip r:embed="rId2"/>
+          <a:stretch>
+            <a:fillRect/>
+          </a:stretch>
+        </p:blipFill>
+        <p:spPr>
+          <a:xfrm>
+            <a:off x="5486400" y="822960"/>
+            <a:ext cx="3474720" cy="3672468"/>
+          </a:xfrm>
+          <a:prstGeom prst="rect">
+            <a:avLst/>
+          </a:prstGeom>
+        </p:spPr>
+      </p:pic>
       <p:sp>
         <p:nvSpPr>
           <p:cNvPr id="2" name="Rectangle 1"/>
@@ -3647,6 +3671,30 @@
         <p:nvPr/>
       </p:nvGrpSpPr>
       <p:grpSpPr/>
+      <p:pic>
+        <p:nvPicPr>
+          <p:cNvPr id="31" name="Picture 30" descr="image.png"/>
+          <p:cNvPicPr>
+            <a:picLocks noChangeAspect="1"/>
+          </p:cNvPicPr>
+          <p:nvPr/>
+        </p:nvPicPr>
+        <p:blipFill>
+          <a:blip r:embed="rId2"/>
+          <a:stretch>
+            <a:fillRect/>
+          </a:stretch>
+        </p:blipFill>
+        <p:spPr>
+          <a:xfrm>
+            <a:off x="5486400" y="822960"/>
+            <a:ext cx="3474720" cy="3645608"/>
+          </a:xfrm>
+          <a:prstGeom prst="rect">
+            <a:avLst/>
+          </a:prstGeom>
+        </p:spPr>
+      </p:pic>
       <p:sp>
         <p:nvSpPr>
           <p:cNvPr id="2" name="Rectangle 1"/>
@@ -4785,6 +4833,30 @@
         <p:nvPr/>
       </p:nvGrpSpPr>
       <p:grpSpPr/>
+      <p:pic>
+        <p:nvPicPr>
+          <p:cNvPr id="22" name="Picture 21" descr="image.png"/>
+          <p:cNvPicPr>
+            <a:picLocks noChangeAspect="1"/>
+          </p:cNvPicPr>
+          <p:nvPr/>
+        </p:nvPicPr>
+        <p:blipFill>
+          <a:blip r:embed="rId2"/>
+          <a:stretch>
+            <a:fillRect/>
+          </a:stretch>
+        </p:blipFill>
+        <p:spPr>
+          <a:xfrm>
+            <a:off x="5303520" y="1371600"/>
+            <a:ext cx="3657600" cy="2406473"/>
+          </a:xfrm>
+          <a:prstGeom prst="rect">
+            <a:avLst/>
+          </a:prstGeom>
+        </p:spPr>
+      </p:pic>
       <p:sp>
         <p:nvSpPr>
           <p:cNvPr id="2" name="Rectangle 1"/>
@@ -5600,6 +5672,30 @@
         <p:nvPr/>
       </p:nvGrpSpPr>
       <p:grpSpPr/>
+      <p:pic>
+        <p:nvPicPr>
+          <p:cNvPr id="22" name="Picture 21" descr="image.png"/>
+          <p:cNvPicPr>
+            <a:picLocks noChangeAspect="1"/>
+          </p:cNvPicPr>
+          <p:nvPr/>
+        </p:nvPicPr>
+        <p:blipFill>
+          <a:blip r:embed="rId2"/>
+          <a:stretch>
+            <a:fillRect/>
+          </a:stretch>
+        </p:blipFill>
+        <p:spPr>
+          <a:xfrm>
+            <a:off x="5212080" y="1371600"/>
+            <a:ext cx="3657600" cy="3042488"/>
+          </a:xfrm>
+          <a:prstGeom prst="rect">
+            <a:avLst/>
+          </a:prstGeom>
+        </p:spPr>
+      </p:pic>
       <p:sp>
         <p:nvSpPr>
           <p:cNvPr id="2" name="Rectangle 1"/>
@@ -6417,6 +6513,30 @@
         <p:nvPr/>
       </p:nvGrpSpPr>
       <p:grpSpPr/>
+      <p:pic>
+        <p:nvPicPr>
+          <p:cNvPr id="22" name="Picture 21" descr="image.png"/>
+          <p:cNvPicPr>
+            <a:picLocks noChangeAspect="1"/>
+          </p:cNvPicPr>
+          <p:nvPr/>
+        </p:nvPicPr>
+        <p:blipFill>
+          <a:blip r:embed="rId2"/>
+          <a:stretch>
+            <a:fillRect/>
+          </a:stretch>
+        </p:blipFill>
+        <p:spPr>
+          <a:xfrm>
+            <a:off x="5577840" y="731520"/>
+            <a:ext cx="3291840" cy="4095248"/>
+          </a:xfrm>
+          <a:prstGeom prst="rect">
+            <a:avLst/>
+          </a:prstGeom>
+        </p:spPr>
+      </p:pic>
       <p:sp>
         <p:nvSpPr>
           <p:cNvPr id="2" name="Rectangle 1"/>
@@ -9756,6 +9876,30 @@
         <p:nvPr/>
       </p:nvGrpSpPr>
       <p:grpSpPr/>
+      <p:pic>
+        <p:nvPicPr>
+          <p:cNvPr id="14" name="Picture 13" descr="image.png"/>
+          <p:cNvPicPr>
+            <a:picLocks noChangeAspect="1"/>
+          </p:cNvPicPr>
+          <p:nvPr/>
+        </p:nvPicPr>
+        <p:blipFill>
+          <a:blip r:embed="rId2"/>
+          <a:stretch>
+            <a:fillRect/>
+          </a:stretch>
+        </p:blipFill>
+        <p:spPr>
+          <a:xfrm>
+            <a:off x="3200400" y="1371600"/>
+            <a:ext cx="2743200" cy="2899317"/>
+          </a:xfrm>
+          <a:prstGeom prst="rect">
+            <a:avLst/>
+          </a:prstGeom>
+        </p:spPr>
+      </p:pic>
       <p:sp>
         <p:nvSpPr>
           <p:cNvPr id="2" name="Rectangle 1"/>

</xml_diff>

<commit_message>
revert: remove overlapping diagrams from presentation
https://claude.ai/code/session_015LB2xF2RT5mgKYrcesBYZQ
</commit_message>
<xml_diff>
--- a/Aufbau_der_Erde.pptx
+++ b/Aufbau_der_Erde.pptx
@@ -3102,30 +3102,6 @@
         <p:nvPr/>
       </p:nvGrpSpPr>
       <p:grpSpPr/>
-      <p:pic>
-        <p:nvPicPr>
-          <p:cNvPr id="15" name="Picture 14" descr="image.png"/>
-          <p:cNvPicPr>
-            <a:picLocks noChangeAspect="1"/>
-          </p:cNvPicPr>
-          <p:nvPr/>
-        </p:nvPicPr>
-        <p:blipFill>
-          <a:blip r:embed="rId2"/>
-          <a:stretch>
-            <a:fillRect/>
-          </a:stretch>
-        </p:blipFill>
-        <p:spPr>
-          <a:xfrm>
-            <a:off x="5486400" y="822960"/>
-            <a:ext cx="3474720" cy="3672468"/>
-          </a:xfrm>
-          <a:prstGeom prst="rect">
-            <a:avLst/>
-          </a:prstGeom>
-        </p:spPr>
-      </p:pic>
       <p:sp>
         <p:nvSpPr>
           <p:cNvPr id="2" name="Rectangle 1"/>
@@ -3671,30 +3647,6 @@
         <p:nvPr/>
       </p:nvGrpSpPr>
       <p:grpSpPr/>
-      <p:pic>
-        <p:nvPicPr>
-          <p:cNvPr id="31" name="Picture 30" descr="image.png"/>
-          <p:cNvPicPr>
-            <a:picLocks noChangeAspect="1"/>
-          </p:cNvPicPr>
-          <p:nvPr/>
-        </p:nvPicPr>
-        <p:blipFill>
-          <a:blip r:embed="rId2"/>
-          <a:stretch>
-            <a:fillRect/>
-          </a:stretch>
-        </p:blipFill>
-        <p:spPr>
-          <a:xfrm>
-            <a:off x="5486400" y="822960"/>
-            <a:ext cx="3474720" cy="3645608"/>
-          </a:xfrm>
-          <a:prstGeom prst="rect">
-            <a:avLst/>
-          </a:prstGeom>
-        </p:spPr>
-      </p:pic>
       <p:sp>
         <p:nvSpPr>
           <p:cNvPr id="2" name="Rectangle 1"/>
@@ -4833,30 +4785,6 @@
         <p:nvPr/>
       </p:nvGrpSpPr>
       <p:grpSpPr/>
-      <p:pic>
-        <p:nvPicPr>
-          <p:cNvPr id="22" name="Picture 21" descr="image.png"/>
-          <p:cNvPicPr>
-            <a:picLocks noChangeAspect="1"/>
-          </p:cNvPicPr>
-          <p:nvPr/>
-        </p:nvPicPr>
-        <p:blipFill>
-          <a:blip r:embed="rId2"/>
-          <a:stretch>
-            <a:fillRect/>
-          </a:stretch>
-        </p:blipFill>
-        <p:spPr>
-          <a:xfrm>
-            <a:off x="5303520" y="1371600"/>
-            <a:ext cx="3657600" cy="2406473"/>
-          </a:xfrm>
-          <a:prstGeom prst="rect">
-            <a:avLst/>
-          </a:prstGeom>
-        </p:spPr>
-      </p:pic>
       <p:sp>
         <p:nvSpPr>
           <p:cNvPr id="2" name="Rectangle 1"/>
@@ -5672,30 +5600,6 @@
         <p:nvPr/>
       </p:nvGrpSpPr>
       <p:grpSpPr/>
-      <p:pic>
-        <p:nvPicPr>
-          <p:cNvPr id="22" name="Picture 21" descr="image.png"/>
-          <p:cNvPicPr>
-            <a:picLocks noChangeAspect="1"/>
-          </p:cNvPicPr>
-          <p:nvPr/>
-        </p:nvPicPr>
-        <p:blipFill>
-          <a:blip r:embed="rId2"/>
-          <a:stretch>
-            <a:fillRect/>
-          </a:stretch>
-        </p:blipFill>
-        <p:spPr>
-          <a:xfrm>
-            <a:off x="5212080" y="1371600"/>
-            <a:ext cx="3657600" cy="3042488"/>
-          </a:xfrm>
-          <a:prstGeom prst="rect">
-            <a:avLst/>
-          </a:prstGeom>
-        </p:spPr>
-      </p:pic>
       <p:sp>
         <p:nvSpPr>
           <p:cNvPr id="2" name="Rectangle 1"/>
@@ -6513,30 +6417,6 @@
         <p:nvPr/>
       </p:nvGrpSpPr>
       <p:grpSpPr/>
-      <p:pic>
-        <p:nvPicPr>
-          <p:cNvPr id="22" name="Picture 21" descr="image.png"/>
-          <p:cNvPicPr>
-            <a:picLocks noChangeAspect="1"/>
-          </p:cNvPicPr>
-          <p:nvPr/>
-        </p:nvPicPr>
-        <p:blipFill>
-          <a:blip r:embed="rId2"/>
-          <a:stretch>
-            <a:fillRect/>
-          </a:stretch>
-        </p:blipFill>
-        <p:spPr>
-          <a:xfrm>
-            <a:off x="5577840" y="731520"/>
-            <a:ext cx="3291840" cy="4095248"/>
-          </a:xfrm>
-          <a:prstGeom prst="rect">
-            <a:avLst/>
-          </a:prstGeom>
-        </p:spPr>
-      </p:pic>
       <p:sp>
         <p:nvSpPr>
           <p:cNvPr id="2" name="Rectangle 1"/>
@@ -9876,30 +9756,6 @@
         <p:nvPr/>
       </p:nvGrpSpPr>
       <p:grpSpPr/>
-      <p:pic>
-        <p:nvPicPr>
-          <p:cNvPr id="14" name="Picture 13" descr="image.png"/>
-          <p:cNvPicPr>
-            <a:picLocks noChangeAspect="1"/>
-          </p:cNvPicPr>
-          <p:nvPr/>
-        </p:nvPicPr>
-        <p:blipFill>
-          <a:blip r:embed="rId2"/>
-          <a:stretch>
-            <a:fillRect/>
-          </a:stretch>
-        </p:blipFill>
-        <p:spPr>
-          <a:xfrm>
-            <a:off x="3200400" y="1371600"/>
-            <a:ext cx="2743200" cy="2899317"/>
-          </a:xfrm>
-          <a:prstGeom prst="rect">
-            <a:avLst/>
-          </a:prstGeom>
-        </p:spPr>
-      </p:pic>
       <p:sp>
         <p:nvSpPr>
           <p:cNvPr id="2" name="Rectangle 1"/>

</xml_diff>

<commit_message>
Revert: remove overlapping diagrams from presentation (#3)
* feat: Karteikarten für Aufbau der Erde Referat

https://claude.ai/code/session_015LB2xF2RT5mgKYrcesBYZQ

* refactor: Karteikarten auf Stichwörter gekürzt

https://claude.ai/code/session_015LB2xF2RT5mgKYrcesBYZQ

* refactor: Karteikarten auf 2 Personen à 2 Min aufgeteilt

https://claude.ai/code/session_015LB2xF2RT5mgKYrcesBYZQ

* revert: remove overlapping diagrams from presentation

https://claude.ai/code/session_015LB2xF2RT5mgKYrcesBYZQ

---------

Co-authored-by: Claude <noreply@anthropic.com>
</commit_message>
<xml_diff>
--- a/Aufbau_der_Erde.pptx
+++ b/Aufbau_der_Erde.pptx
@@ -3102,30 +3102,6 @@
         <p:nvPr/>
       </p:nvGrpSpPr>
       <p:grpSpPr/>
-      <p:pic>
-        <p:nvPicPr>
-          <p:cNvPr id="15" name="Picture 14" descr="image.png"/>
-          <p:cNvPicPr>
-            <a:picLocks noChangeAspect="1"/>
-          </p:cNvPicPr>
-          <p:nvPr/>
-        </p:nvPicPr>
-        <p:blipFill>
-          <a:blip r:embed="rId2"/>
-          <a:stretch>
-            <a:fillRect/>
-          </a:stretch>
-        </p:blipFill>
-        <p:spPr>
-          <a:xfrm>
-            <a:off x="5486400" y="822960"/>
-            <a:ext cx="3474720" cy="3672468"/>
-          </a:xfrm>
-          <a:prstGeom prst="rect">
-            <a:avLst/>
-          </a:prstGeom>
-        </p:spPr>
-      </p:pic>
       <p:sp>
         <p:nvSpPr>
           <p:cNvPr id="2" name="Rectangle 1"/>
@@ -3671,30 +3647,6 @@
         <p:nvPr/>
       </p:nvGrpSpPr>
       <p:grpSpPr/>
-      <p:pic>
-        <p:nvPicPr>
-          <p:cNvPr id="31" name="Picture 30" descr="image.png"/>
-          <p:cNvPicPr>
-            <a:picLocks noChangeAspect="1"/>
-          </p:cNvPicPr>
-          <p:nvPr/>
-        </p:nvPicPr>
-        <p:blipFill>
-          <a:blip r:embed="rId2"/>
-          <a:stretch>
-            <a:fillRect/>
-          </a:stretch>
-        </p:blipFill>
-        <p:spPr>
-          <a:xfrm>
-            <a:off x="5486400" y="822960"/>
-            <a:ext cx="3474720" cy="3645608"/>
-          </a:xfrm>
-          <a:prstGeom prst="rect">
-            <a:avLst/>
-          </a:prstGeom>
-        </p:spPr>
-      </p:pic>
       <p:sp>
         <p:nvSpPr>
           <p:cNvPr id="2" name="Rectangle 1"/>
@@ -4833,30 +4785,6 @@
         <p:nvPr/>
       </p:nvGrpSpPr>
       <p:grpSpPr/>
-      <p:pic>
-        <p:nvPicPr>
-          <p:cNvPr id="22" name="Picture 21" descr="image.png"/>
-          <p:cNvPicPr>
-            <a:picLocks noChangeAspect="1"/>
-          </p:cNvPicPr>
-          <p:nvPr/>
-        </p:nvPicPr>
-        <p:blipFill>
-          <a:blip r:embed="rId2"/>
-          <a:stretch>
-            <a:fillRect/>
-          </a:stretch>
-        </p:blipFill>
-        <p:spPr>
-          <a:xfrm>
-            <a:off x="5303520" y="1371600"/>
-            <a:ext cx="3657600" cy="2406473"/>
-          </a:xfrm>
-          <a:prstGeom prst="rect">
-            <a:avLst/>
-          </a:prstGeom>
-        </p:spPr>
-      </p:pic>
       <p:sp>
         <p:nvSpPr>
           <p:cNvPr id="2" name="Rectangle 1"/>
@@ -5672,30 +5600,6 @@
         <p:nvPr/>
       </p:nvGrpSpPr>
       <p:grpSpPr/>
-      <p:pic>
-        <p:nvPicPr>
-          <p:cNvPr id="22" name="Picture 21" descr="image.png"/>
-          <p:cNvPicPr>
-            <a:picLocks noChangeAspect="1"/>
-          </p:cNvPicPr>
-          <p:nvPr/>
-        </p:nvPicPr>
-        <p:blipFill>
-          <a:blip r:embed="rId2"/>
-          <a:stretch>
-            <a:fillRect/>
-          </a:stretch>
-        </p:blipFill>
-        <p:spPr>
-          <a:xfrm>
-            <a:off x="5212080" y="1371600"/>
-            <a:ext cx="3657600" cy="3042488"/>
-          </a:xfrm>
-          <a:prstGeom prst="rect">
-            <a:avLst/>
-          </a:prstGeom>
-        </p:spPr>
-      </p:pic>
       <p:sp>
         <p:nvSpPr>
           <p:cNvPr id="2" name="Rectangle 1"/>
@@ -6513,30 +6417,6 @@
         <p:nvPr/>
       </p:nvGrpSpPr>
       <p:grpSpPr/>
-      <p:pic>
-        <p:nvPicPr>
-          <p:cNvPr id="22" name="Picture 21" descr="image.png"/>
-          <p:cNvPicPr>
-            <a:picLocks noChangeAspect="1"/>
-          </p:cNvPicPr>
-          <p:nvPr/>
-        </p:nvPicPr>
-        <p:blipFill>
-          <a:blip r:embed="rId2"/>
-          <a:stretch>
-            <a:fillRect/>
-          </a:stretch>
-        </p:blipFill>
-        <p:spPr>
-          <a:xfrm>
-            <a:off x="5577840" y="731520"/>
-            <a:ext cx="3291840" cy="4095248"/>
-          </a:xfrm>
-          <a:prstGeom prst="rect">
-            <a:avLst/>
-          </a:prstGeom>
-        </p:spPr>
-      </p:pic>
       <p:sp>
         <p:nvSpPr>
           <p:cNvPr id="2" name="Rectangle 1"/>
@@ -9876,30 +9756,6 @@
         <p:nvPr/>
       </p:nvGrpSpPr>
       <p:grpSpPr/>
-      <p:pic>
-        <p:nvPicPr>
-          <p:cNvPr id="14" name="Picture 13" descr="image.png"/>
-          <p:cNvPicPr>
-            <a:picLocks noChangeAspect="1"/>
-          </p:cNvPicPr>
-          <p:nvPr/>
-        </p:nvPicPr>
-        <p:blipFill>
-          <a:blip r:embed="rId2"/>
-          <a:stretch>
-            <a:fillRect/>
-          </a:stretch>
-        </p:blipFill>
-        <p:spPr>
-          <a:xfrm>
-            <a:off x="3200400" y="1371600"/>
-            <a:ext cx="2743200" cy="2899317"/>
-          </a:xfrm>
-          <a:prstGeom prst="rect">
-            <a:avLst/>
-          </a:prstGeom>
-        </p:spPr>
-      </p:pic>
       <p:sp>
         <p:nvSpPr>
           <p:cNvPr id="2" name="Rectangle 1"/>

</xml_diff>